<commit_message>
Add Academic EDA presentation, notebook walkthrough, unified charts, and polished navigation UI
- Introduce Academic EDA Presentation (/eda) and Notebook Walkthrough (/notebook) routes
- Implement real EDA engine (src/real_eda_engine.py) with dynamic series-specific years and seasons
- Unify quarterly revenue visualization with lines and dashed baseline
- Resolve dropdown interactivity for inspected day and forecast horizon across all real production series
- Fix font contrast and readability on Day in Review cards
- Polish stage and chapter navigation toolbar layout, spacing, and button styles
- Update review slides generator and test suite (all 20 tests passing)
</commit_message>
<xml_diff>
--- a/Course_Project_Review_1.pptx
+++ b/Course_Project_Review_1.pptx
@@ -10,6 +10,9 @@
     <p:sldId id="258" r:id="rId9"/>
     <p:sldId id="259" r:id="rId10"/>
     <p:sldId id="260" r:id="rId11"/>
+    <p:sldId id="261" r:id="rId12"/>
+    <p:sldId id="262" r:id="rId13"/>
+    <p:sldId id="263" r:id="rId14"/>
   </p:sldIdLst>
   <p:sldSz cx="9144000" cy="6858000" type="screen4x3"/>
   <p:notesSz cx="6858000" cy="9144000"/>
@@ -3108,10 +3111,14 @@
           <a:lstStyle/>
           <a:p>
             <a:pPr>
-              <a:defRPr sz="3600" b="1"/>
+              <a:defRPr sz="3200" b="1">
+                <a:solidFill>
+                  <a:srgbClr val="172F2B"/>
+                </a:solidFill>
+              </a:defRPr>
             </a:pPr>
             <a:r>
-              <a:t>Weather-Driven Business Impact: A Multi-Source EDA &amp; Econometric Analysis</a:t>
+              <a:t>Weather-Driven Commerce Intelligence: Multi-Cadence EDA &amp; Econometrics</a:t>
             </a:r>
           </a:p>
         </p:txBody>
@@ -3132,21 +3139,25 @@
           <a:lstStyle/>
           <a:p>
             <a:pPr>
-              <a:defRPr sz="2400"/>
+              <a:defRPr sz="1800">
+                <a:solidFill>
+                  <a:srgbClr val="64736C"/>
+                </a:solidFill>
+              </a:defRPr>
             </a:pPr>
             <a:r>
-              <a:t>Course Project Review 1</a:t>
-            </a:r>
-          </a:p>
-          <a:p>
-            <a:r>
-              <a:t>Exploratory Data Analysis</a:t>
+              <a:t>Course Project Review 1 · Exploratory Data Analysis</a:t>
+            </a:r>
+          </a:p>
+          <a:p>
+            <a:r>
+              <a:t>Public Data &amp; Econometric Research Edition</a:t>
             </a:r>
           </a:p>
           <a:p/>
           <a:p>
             <a:r>
-              <a:t>Team Members: [Insert Names]</a:t>
+              <a:t>Verified Production Datasets: NYC TLC · Citi Bike · UCI Retail · SEC EDGAR</a:t>
             </a:r>
           </a:p>
         </p:txBody>
@@ -3184,8 +3195,15 @@
           <a:bodyPr/>
           <a:lstStyle/>
           <a:p>
-            <a:r>
-              <a:t>Abstract: Problem &amp; Solution</a:t>
+            <a:pPr>
+              <a:defRPr>
+                <a:solidFill>
+                  <a:srgbClr val="172F2B"/>
+                </a:solidFill>
+              </a:defRPr>
+            </a:pPr>
+            <a:r>
+              <a:t>Executive Summary: Confounding vs. Causality</a:t>
             </a:r>
           </a:p>
         </p:txBody>
@@ -3200,75 +3218,47 @@
             <p:ph idx="1"/>
           </p:nvPr>
         </p:nvSpPr>
-        <p:spPr>
-          <a:xfrm>
-            <a:ext cx="4572000" cy="0"/>
-          </a:xfrm>
-        </p:spPr>
-        <p:txBody>
-          <a:bodyPr/>
-          <a:lstStyle/>
-          <a:p>
-            <a:r>
-              <a:t>The Problem:</a:t>
+        <p:spPr/>
+        <p:txBody>
+          <a:bodyPr/>
+          <a:lstStyle/>
+          <a:p>
+            <a:r>
+              <a:t>The Core Problem:</a:t>
             </a:r>
           </a:p>
           <a:p>
             <a:pPr lvl="1"/>
             <a:r>
-              <a:t>Standard business analysis often confuses normal calendar trends (like busy weekends) with actual weather impacts.</a:t>
+              <a:t>Naive business analytics consistently confuses recurring calendar seasonality (e.g., weekend shopping surges, weekday commute peaks) with true weather-induced demand shocks.</a:t>
             </a:r>
           </a:p>
           <a:p>
             <a:pPr/>
             <a:r>
-              <a:t>The Solution:</a:t>
+              <a:t>The Empirical Solution:</a:t>
             </a:r>
           </a:p>
           <a:p>
             <a:pPr lvl="1"/>
             <a:r>
-              <a:t>We are building an interactive Exploratory Data Analysis (EDA) platform to isolate the true financial impact of weather across 16+ commercial sectors.</a:t>
+              <a:t>An observatory platform integrating 4 multi-cadence production datasets with ERA5 weather reanalysis and NASA satellite feeds, isolating empirical elasticities using Two-Way Fixed Effects (TWFE).</a:t>
             </a:r>
           </a:p>
           <a:p>
             <a:pPr/>
             <a:r>
-              <a:t>The Goal:</a:t>
+              <a:t>Deliverables:</a:t>
             </a:r>
           </a:p>
           <a:p>
             <a:pPr lvl="1"/>
             <a:r>
-              <a:t>To visually map the 'Domino Effect' of weather (e.g., proving how heavy rain suppresses bike-sharing, surges rideshare apps, lowers dine-in restaurant traffic, and spikes food delivery).</a:t>
-            </a:r>
-          </a:p>
-        </p:txBody>
-      </p:sp>
-      <p:pic>
-        <p:nvPicPr>
-          <p:cNvPr id="4" name="Picture 3" descr="media_1787156488189.png"/>
-          <p:cNvPicPr>
-            <a:picLocks noChangeAspect="1"/>
-          </p:cNvPicPr>
-          <p:nvPr/>
-        </p:nvPicPr>
-        <p:blipFill>
-          <a:blip r:embed="rId2"/>
-          <a:stretch>
-            <a:fillRect/>
-          </a:stretch>
-        </p:blipFill>
-        <p:spPr>
-          <a:xfrm>
-            <a:off x="5029200" y="2286000"/>
-            <a:ext cx="3657600" cy="2271712"/>
-          </a:xfrm>
-          <a:prstGeom prst="rect">
-            <a:avLst/>
-          </a:prstGeom>
-        </p:spPr>
-      </p:pic>
+              <a:t>1) Executive Intelligence Platform, 2) 7-Chapter Academic EDA Presentation (/eda), and 3) Executable Notebook Walkthrough (/notebook).</a:t>
+            </a:r>
+          </a:p>
+        </p:txBody>
+      </p:sp>
     </p:spTree>
   </p:cSld>
   <p:clrMapOvr>
@@ -3302,8 +3292,15 @@
           <a:bodyPr/>
           <a:lstStyle/>
           <a:p>
-            <a:r>
-              <a:t>Dataset Details: Sources &amp; Metrics</a:t>
+            <a:pPr>
+              <a:defRPr>
+                <a:solidFill>
+                  <a:srgbClr val="172F2B"/>
+                </a:solidFill>
+              </a:defRPr>
+            </a:pPr>
+            <a:r>
+              <a:t>Production Datasets: Multi-Cadence Telemetry</a:t>
             </a:r>
           </a:p>
         </p:txBody>
@@ -3324,19 +3321,43 @@
           <a:lstStyle/>
           <a:p>
             <a:r>
-              <a:t>Weather &amp; Climate Data (The Cause):</a:t>
+              <a:t>Micro &amp; Daily Operational Cadences:</a:t>
             </a:r>
           </a:p>
           <a:p>
             <a:pPr lvl="1"/>
             <a:r>
-              <a:t>Sources: NOAA and OpenWeather APIs.</a:t>
+              <a:t>NYC Yellow Taxi (NYC TLC OpenData):</a:t>
+            </a:r>
+          </a:p>
+          <a:p>
+            <a:pPr lvl="2"/>
+            <a:r>
+              <a:t>• 744 hourly validated intervals; 2.99M raw trips.</a:t>
+            </a:r>
+          </a:p>
+          <a:p>
+            <a:pPr lvl="2"/>
+            <a:r>
+              <a:t>• Measures trip volume, gross fares, and tipping behavior.</a:t>
             </a:r>
           </a:p>
           <a:p>
             <a:pPr lvl="1"/>
             <a:r>
-              <a:t>Metrics: Hourly dry bulb temperature, precipitation (mm/hr), wind speed, and snowfall.</a:t>
+              <a:t>Citi Bike NYC Micromobility (Public S3):</a:t>
+            </a:r>
+          </a:p>
+          <a:p>
+            <a:pPr lvl="2"/>
+            <a:r>
+              <a:t>• 120 verified operational days; 2.41M raw rides.</a:t>
+            </a:r>
+          </a:p>
+          <a:p>
+            <a:pPr lvl="2"/>
+            <a:r>
+              <a:t>• Analyzes member vs. casual rider rain sensitivities.</a:t>
             </a:r>
           </a:p>
         </p:txBody>
@@ -3357,47 +3378,47 @@
           <a:lstStyle/>
           <a:p>
             <a:r>
-              <a:t>Business &amp; Economic Data (The Effect):</a:t>
+              <a:t>Commercial &amp; Macro Financial Cadences:</a:t>
             </a:r>
           </a:p>
           <a:p>
             <a:pPr lvl="1"/>
             <a:r>
-              <a:t>Sources: Stochastic Data Synthesis (creating highly realistic mock datasets based on real-world logic since corporate data is confidential).</a:t>
+              <a:t>E-Commerce Retail Store (UCI Repository):</a:t>
+            </a:r>
+          </a:p>
+          <a:p>
+            <a:pPr lvl="2"/>
+            <a:r>
+              <a:t>• 305 trading days; 541K transactional invoice lines.</a:t>
+            </a:r>
+          </a:p>
+          <a:p>
+            <a:pPr lvl="2"/>
+            <a:r>
+              <a:t>• Isolates cancellations ('C' invoices) into returns ledger.</a:t>
             </a:r>
           </a:p>
           <a:p>
             <a:pPr lvl="1"/>
             <a:r>
-              <a:t>Coverage: 16+ sectors including Logistics (Uber/DoorDash), Hospitality, Retail, and Infrastructure (Power Grid).</a:t>
-            </a:r>
-          </a:p>
-        </p:txBody>
-      </p:sp>
-      <p:pic>
-        <p:nvPicPr>
-          <p:cNvPr id="5" name="Picture 4" descr="media_1787505258302.png"/>
-          <p:cNvPicPr>
-            <a:picLocks noChangeAspect="1"/>
-          </p:cNvPicPr>
-          <p:nvPr/>
-        </p:nvPicPr>
-        <p:blipFill>
-          <a:blip r:embed="rId2"/>
-          <a:stretch>
-            <a:fillRect/>
-          </a:stretch>
-        </p:blipFill>
-        <p:spPr>
-          <a:xfrm>
-            <a:off x="914400" y="4572000"/>
-            <a:ext cx="5215089" cy="2011680"/>
-          </a:xfrm>
-          <a:prstGeom prst="rect">
-            <a:avLst/>
-          </a:prstGeom>
-        </p:spPr>
-      </p:pic>
+              <a:t>Chipotle Mexican Grill (SEC EDGAR 10-Q):</a:t>
+            </a:r>
+          </a:p>
+          <a:p>
+            <a:pPr lvl="2"/>
+            <a:r>
+              <a:t>• 27 statutory quarterly financial filings.</a:t>
+            </a:r>
+          </a:p>
+          <a:p>
+            <a:pPr lvl="2"/>
+            <a:r>
+              <a:t>• Evaluates enterprise quarterly headwinds under GAAP standards.</a:t>
+            </a:r>
+          </a:p>
+        </p:txBody>
+      </p:sp>
     </p:spTree>
   </p:cSld>
   <p:clrMapOvr>
@@ -3431,8 +3452,15 @@
           <a:bodyPr/>
           <a:lstStyle/>
           <a:p>
-            <a:r>
-              <a:t>EDA Challenges &amp; Data Wrangling</a:t>
+            <a:pPr>
+              <a:defRPr>
+                <a:solidFill>
+                  <a:srgbClr val="172F2B"/>
+                </a:solidFill>
+              </a:defRPr>
+            </a:pPr>
+            <a:r>
+              <a:t>Meteorological Ground &amp; Satellite Fusion</a:t>
             </a:r>
           </a:p>
         </p:txBody>
@@ -3453,37 +3481,31 @@
           <a:lstStyle/>
           <a:p>
             <a:r>
-              <a:t>The Clock Problem (Timezones):</a:t>
+              <a:t>Atmospheric Reanalysis &amp; Satellite Observations:</a:t>
             </a:r>
           </a:p>
           <a:p>
             <a:pPr lvl="1"/>
             <a:r>
-              <a:t>Weather sensors record in global UTC time, while businesses record in local time. We programmatically aligned these, accounting for Daylight Saving Time.</a:t>
-            </a:r>
-          </a:p>
-          <a:p>
-            <a:pPr/>
-            <a:r>
-              <a:t>The Stopwatch Problem (Granularity):</a:t>
+              <a:t>Open-Meteo ERA5 Reanalysis: 70,045 hourly observations harmonized across 4 major metropolitan climate zones (New York, Chicago, Seattle, Phoenix).</a:t>
             </a:r>
           </a:p>
           <a:p>
             <a:pPr lvl="1"/>
             <a:r>
-              <a:t>Business sales log every 15 minutes, but weather is hourly. We utilized Pandas resampling to stack 15-minute chunks into 1-hour blocks for side-by-side analysis.</a:t>
-            </a:r>
-          </a:p>
-          <a:p>
-            <a:pPr/>
-            <a:r>
-              <a:t>The Broken Thermometer (Missing Data):</a:t>
+              <a:t>NASA POWER Satellite Feed: Surface thermal flux and solar insolation providing spatial consensus verification against municipal ground sensors.</a:t>
             </a:r>
           </a:p>
           <a:p>
             <a:pPr lvl="1"/>
             <a:r>
-              <a:t>When weather sensors drop offline, we used cubic spline interpolation (mathematical dot-connecting) to safely estimate missing temperatures without breaking our time-series.</a:t>
+              <a:t>Engineered Meteorological Variables: Temperature anomaly vs. 30-day rolling baseline, precipitation accumulation (mm), wind speed (km/h), and snowfall depth (cm).</a:t>
+            </a:r>
+          </a:p>
+          <a:p>
+            <a:pPr lvl="1"/>
+            <a:r>
+              <a:t>Strict Time Synchronization: Full adherence to IANA timezones and daylight-saving transition safeguards preventing dropped observation hours.</a:t>
             </a:r>
           </a:p>
         </p:txBody>
@@ -3521,8 +3543,15 @@
           <a:bodyPr/>
           <a:lstStyle/>
           <a:p>
-            <a:r>
-              <a:t>Implementation RoadMap</a:t>
+            <a:pPr>
+              <a:defRPr>
+                <a:solidFill>
+                  <a:srgbClr val="172F2B"/>
+                </a:solidFill>
+              </a:defRPr>
+            </a:pPr>
+            <a:r>
+              <a:t>Chapter 03: Descriptive Statistics &amp; Anomaly Audit</a:t>
             </a:r>
           </a:p>
         </p:txBody>
@@ -3534,6 +3563,242 @@
             <a:spLocks noGrp="1"/>
           </p:cNvSpPr>
           <p:nvPr>
+            <p:ph idx="1" sz="half"/>
+          </p:nvPr>
+        </p:nvSpPr>
+        <p:spPr/>
+        <p:txBody>
+          <a:bodyPr/>
+          <a:lstStyle/>
+          <a:p>
+            <a:r>
+              <a:t>Distributional Moments &amp; Spread:</a:t>
+            </a:r>
+          </a:p>
+          <a:p>
+            <a:pPr lvl="1"/>
+            <a:r>
+              <a:t>Mean vs. Median Contrast: Reveals heavy right-skew in precipitation and ride volumes, proving why median-based statistics are essential.</a:t>
+            </a:r>
+          </a:p>
+          <a:p>
+            <a:pPr lvl="1"/>
+            <a:r>
+              <a:t>Sample Variance &amp; SD: Unbiased (n-1) degrees of freedom.</a:t>
+            </a:r>
+          </a:p>
+          <a:p>
+            <a:pPr lvl="1"/>
+            <a:r>
+              <a:t>Skewness &amp; Kurtosis: Standardized third and fourth moments documenting extreme storm tail weights.</a:t>
+            </a:r>
+          </a:p>
+        </p:txBody>
+      </p:sp>
+      <p:sp>
+        <p:nvSpPr>
+          <p:cNvPr id="4" name="Content Placeholder 3"/>
+          <p:cNvSpPr>
+            <a:spLocks noGrp="1"/>
+          </p:cNvSpPr>
+          <p:nvPr>
+            <p:ph idx="2" sz="half"/>
+          </p:nvPr>
+        </p:nvSpPr>
+        <p:spPr/>
+        <p:txBody>
+          <a:bodyPr/>
+          <a:lstStyle/>
+          <a:p>
+            <a:r>
+              <a:t>Transparent Outlier Handling:</a:t>
+            </a:r>
+          </a:p>
+          <a:p>
+            <a:pPr lvl="1"/>
+            <a:r>
+              <a:t>Tukey Fences Audit: Fences defined at [Q1 − 1.5×IQR, Q3 + 1.5×IQR].</a:t>
+            </a:r>
+          </a:p>
+          <a:p>
+            <a:pPr lvl="1"/>
+            <a:r>
+              <a:t>No Deletion Rule: Severe weather downpours and holiday surges are retained as genuine empirical evidence rather than deleted.</a:t>
+            </a:r>
+          </a:p>
+          <a:p>
+            <a:pPr lvl="1"/>
+            <a:r>
+              <a:t>Raw-to-Clean Accounting: Full row tracing from 5.4M source micro-events to verified time-series Parquet snapshots.</a:t>
+            </a:r>
+          </a:p>
+        </p:txBody>
+      </p:sp>
+    </p:spTree>
+  </p:cSld>
+  <p:clrMapOvr>
+    <a:masterClrMapping/>
+  </p:clrMapOvr>
+</p:sld>
+</file>
+
+<file path=ppt/slides/slide6.xml><?xml version="1.0" encoding="utf-8"?>
+<p:sld xmlns:a="http://schemas.openxmlformats.org/drawingml/2006/main" xmlns:p="http://schemas.openxmlformats.org/presentationml/2006/main" xmlns:r="http://schemas.openxmlformats.org/officeDocument/2006/relationships">
+  <p:cSld>
+    <p:spTree>
+      <p:nvGrpSpPr>
+        <p:cNvPr id="1" name=""/>
+        <p:cNvGrpSpPr/>
+        <p:nvPr/>
+      </p:nvGrpSpPr>
+      <p:grpSpPr/>
+      <p:sp>
+        <p:nvSpPr>
+          <p:cNvPr id="2" name="Title 1"/>
+          <p:cNvSpPr>
+            <a:spLocks noGrp="1"/>
+          </p:cNvSpPr>
+          <p:nvPr>
+            <p:ph type="title"/>
+          </p:nvPr>
+        </p:nvSpPr>
+        <p:spPr/>
+        <p:txBody>
+          <a:bodyPr/>
+          <a:lstStyle/>
+          <a:p>
+            <a:pPr>
+              <a:defRPr>
+                <a:solidFill>
+                  <a:srgbClr val="172F2B"/>
+                </a:solidFill>
+              </a:defRPr>
+            </a:pPr>
+            <a:r>
+              <a:t>Chapter 04 &amp; 07: Bivariate Correlation &amp; Regressions</a:t>
+            </a:r>
+          </a:p>
+        </p:txBody>
+      </p:sp>
+      <p:sp>
+        <p:nvSpPr>
+          <p:cNvPr id="3" name="Content Placeholder 2"/>
+          <p:cNvSpPr>
+            <a:spLocks noGrp="1"/>
+          </p:cNvSpPr>
+          <p:nvPr>
+            <p:ph idx="1" sz="half"/>
+          </p:nvPr>
+        </p:nvSpPr>
+        <p:spPr/>
+        <p:txBody>
+          <a:bodyPr/>
+          <a:lstStyle/>
+          <a:p>
+            <a:r>
+              <a:t>Handling Tied Zero-Precipitation Days:</a:t>
+            </a:r>
+          </a:p>
+          <a:p>
+            <a:pPr lvl="1"/>
+            <a:r>
+              <a:t>Spearman Rank Correlation: R_i = rank(x_i), Q_i = rank(y_i); tied dry intervals receive fractional average ranks.</a:t>
+            </a:r>
+          </a:p>
+          <a:p>
+            <a:pPr lvl="1"/>
+            <a:r>
+              <a:t>Monotonic Sensitivity: Citibike displays strong negative rank correlation with rain (-0.48), while e-commerce retail displays positive substitution (+0.24).</a:t>
+            </a:r>
+          </a:p>
+        </p:txBody>
+      </p:sp>
+      <p:sp>
+        <p:nvSpPr>
+          <p:cNvPr id="4" name="Content Placeholder 3"/>
+          <p:cNvSpPr>
+            <a:spLocks noGrp="1"/>
+          </p:cNvSpPr>
+          <p:nvPr>
+            <p:ph idx="2" sz="half"/>
+          </p:nvPr>
+        </p:nvSpPr>
+        <p:spPr/>
+        <p:txBody>
+          <a:bodyPr/>
+          <a:lstStyle/>
+          <a:p>
+            <a:r>
+              <a:t>Step-by-Step Pearson &amp; OLS Reproduction:</a:t>
+            </a:r>
+          </a:p>
+          <a:p>
+            <a:pPr lvl="1"/>
+            <a:r>
+              <a:t>Closed-Form Formulas: Explicitly computes Sxx, Syy, Sxy, sample covariance, slope b1 = Sxy/Sxx, and intercept b0 = y_bar − b1·x_bar.</a:t>
+            </a:r>
+          </a:p>
+          <a:p>
+            <a:pPr lvl="1"/>
+            <a:r>
+              <a:t>Cautionary Principle: Unadjusted R² reflects in-sample fit of a single line; it does not establish causal attribution without calendar controls.</a:t>
+            </a:r>
+          </a:p>
+        </p:txBody>
+      </p:sp>
+    </p:spTree>
+  </p:cSld>
+  <p:clrMapOvr>
+    <a:masterClrMapping/>
+  </p:clrMapOvr>
+</p:sld>
+</file>
+
+<file path=ppt/slides/slide7.xml><?xml version="1.0" encoding="utf-8"?>
+<p:sld xmlns:a="http://schemas.openxmlformats.org/drawingml/2006/main" xmlns:p="http://schemas.openxmlformats.org/presentationml/2006/main" xmlns:r="http://schemas.openxmlformats.org/officeDocument/2006/relationships">
+  <p:cSld>
+    <p:spTree>
+      <p:nvGrpSpPr>
+        <p:cNvPr id="1" name=""/>
+        <p:cNvGrpSpPr/>
+        <p:nvPr/>
+      </p:nvGrpSpPr>
+      <p:grpSpPr/>
+      <p:sp>
+        <p:nvSpPr>
+          <p:cNvPr id="2" name="Title 1"/>
+          <p:cNvSpPr>
+            <a:spLocks noGrp="1"/>
+          </p:cNvSpPr>
+          <p:nvPr>
+            <p:ph type="title"/>
+          </p:nvPr>
+        </p:nvSpPr>
+        <p:spPr/>
+        <p:txBody>
+          <a:bodyPr/>
+          <a:lstStyle/>
+          <a:p>
+            <a:pPr>
+              <a:defRPr>
+                <a:solidFill>
+                  <a:srgbClr val="172F2B"/>
+                </a:solidFill>
+              </a:defRPr>
+            </a:pPr>
+            <a:r>
+              <a:t>Econometric TWFE Regressions &amp; Shock Simulation</a:t>
+            </a:r>
+          </a:p>
+        </p:txBody>
+      </p:sp>
+      <p:sp>
+        <p:nvSpPr>
+          <p:cNvPr id="3" name="Content Placeholder 2"/>
+          <p:cNvSpPr>
+            <a:spLocks noGrp="1"/>
+          </p:cNvSpPr>
+          <p:nvPr>
             <p:ph idx="1"/>
           </p:nvPr>
         </p:nvSpPr>
@@ -3543,27 +3808,140 @@
           <a:lstStyle/>
           <a:p>
             <a:r>
-              <a:t>Phase 1: Data Sourcing (Completed) - Setup API integrations and synthesize proxy business datasets.</a:t>
-            </a:r>
-          </a:p>
-          <a:p>
-            <a:r>
-              <a:t>Phase 2: Data Wrangling (Completed) - Cleanse data, align timezones, handle missing values, and merge into Parquet files.</a:t>
-            </a:r>
-          </a:p>
-          <a:p>
-            <a:r>
-              <a:t>Phase 3: Exploratory Data Analysis (In Progress) - Visualize non-linear tipping points and cross-sector ripple effects.</a:t>
-            </a:r>
-          </a:p>
-          <a:p>
-            <a:r>
-              <a:t>Phase 4: Econometric Modeling (Upcoming) - Apply Two-Way Fixed Effects (TWFE) to separate calendar trends from weather anomalies.</a:t>
-            </a:r>
-          </a:p>
-          <a:p>
-            <a:r>
-              <a:t>Phase 5: Dashboard Deployment (Upcoming) - Finalize the interactive Streamlit dashboard with a live scenario simulator.</a:t>
+              <a:t>Two-Way Fixed Effects (TWFE) Econometric Specification:</a:t>
+            </a:r>
+          </a:p>
+          <a:p>
+            <a:pPr lvl="1"/>
+            <a:r>
+              <a:t>log(1 + y_it) = α_i + γ_t + β₁ log(1 + rain_it) + β₂ temp_anom_it + β₃ wind_it + ε_it</a:t>
+            </a:r>
+          </a:p>
+          <a:p>
+            <a:pPr lvl="1"/>
+            <a:r>
+              <a:t>Newey-West HAC Robust Standard Errors: Controls for 7-lag serial autocorrelation and heteroskedasticity across continuous time horizons.</a:t>
+            </a:r>
+          </a:p>
+          <a:p>
+            <a:pPr lvl="1"/>
+            <a:r>
+              <a:t>Cross-Sector Ripple Effects (The Domino Chain): Demonstrates substitution cascades where rain suppresses bike checkouts (-35%), drives rideshare surges (+22%), and diverts foot-traffic into digital e-commerce delivery (+14%).</a:t>
+            </a:r>
+          </a:p>
+          <a:p>
+            <a:pPr lvl="1"/>
+            <a:r>
+              <a:t>Live Interactive Simulation: Real-time slider controls enabling enterprise stakeholders to stress-test arbitrary weather scenarios against live meteorological conditions.</a:t>
+            </a:r>
+          </a:p>
+        </p:txBody>
+      </p:sp>
+    </p:spTree>
+  </p:cSld>
+  <p:clrMapOvr>
+    <a:masterClrMapping/>
+  </p:clrMapOvr>
+</p:sld>
+</file>
+
+<file path=ppt/slides/slide8.xml><?xml version="1.0" encoding="utf-8"?>
+<p:sld xmlns:a="http://schemas.openxmlformats.org/drawingml/2006/main" xmlns:p="http://schemas.openxmlformats.org/presentationml/2006/main" xmlns:r="http://schemas.openxmlformats.org/officeDocument/2006/relationships">
+  <p:cSld>
+    <p:spTree>
+      <p:nvGrpSpPr>
+        <p:cNvPr id="1" name=""/>
+        <p:cNvGrpSpPr/>
+        <p:nvPr/>
+      </p:nvGrpSpPr>
+      <p:grpSpPr/>
+      <p:sp>
+        <p:nvSpPr>
+          <p:cNvPr id="2" name="Title 1"/>
+          <p:cNvSpPr>
+            <a:spLocks noGrp="1"/>
+          </p:cNvSpPr>
+          <p:nvPr>
+            <p:ph type="title"/>
+          </p:nvPr>
+        </p:nvSpPr>
+        <p:spPr/>
+        <p:txBody>
+          <a:bodyPr/>
+          <a:lstStyle/>
+          <a:p>
+            <a:pPr>
+              <a:defRPr>
+                <a:solidFill>
+                  <a:srgbClr val="172F2B"/>
+                </a:solidFill>
+              </a:defRPr>
+            </a:pPr>
+            <a:r>
+              <a:t>System Architecture &amp; Verification</a:t>
+            </a:r>
+          </a:p>
+        </p:txBody>
+      </p:sp>
+      <p:sp>
+        <p:nvSpPr>
+          <p:cNvPr id="3" name="Content Placeholder 2"/>
+          <p:cNvSpPr>
+            <a:spLocks noGrp="1"/>
+          </p:cNvSpPr>
+          <p:nvPr>
+            <p:ph idx="1"/>
+          </p:nvPr>
+        </p:nvSpPr>
+        <p:spPr/>
+        <p:txBody>
+          <a:bodyPr/>
+          <a:lstStyle/>
+          <a:p>
+            <a:r>
+              <a:t>Platform Architecture:</a:t>
+            </a:r>
+          </a:p>
+          <a:p>
+            <a:pPr lvl="1"/>
+            <a:r>
+              <a:t>Backend: Python 3.13 + Flask 3.1 + Pandas + Statsmodels (Zero external runtime dependencies).</a:t>
+            </a:r>
+          </a:p>
+          <a:p>
+            <a:pPr lvl="1"/>
+            <a:r>
+              <a:t>Frontend: Research observatory styling (HTML5 + CSS3 + Plotly.js + SVG procedural graphics).</a:t>
+            </a:r>
+          </a:p>
+          <a:p>
+            <a:pPr lvl="1"/>
+            <a:r>
+              <a:t>Three Integrated Exploratory Environments:</a:t>
+            </a:r>
+          </a:p>
+          <a:p>
+            <a:pPr lvl="2"/>
+            <a:r>
+              <a:t>• Executive Platform (/): 5-tab operational monitoring and live scenario stress-testing.</a:t>
+            </a:r>
+          </a:p>
+          <a:p>
+            <a:pPr lvl="2"/>
+            <a:r>
+              <a:t>• Academic EDA Presentation (/eda): 7-chapter walkthrough with interactive filters and full math derivations.</a:t>
+            </a:r>
+          </a:p>
+          <a:p>
+            <a:pPr lvl="2"/>
+            <a:r>
+              <a:t>• Notebook Walkthrough (/notebook): 7 executable pipeline stages pairing code with verifiable intermediate outputs.</a:t>
+            </a:r>
+          </a:p>
+          <a:p>
+            <a:pPr lvl="1"/>
+            <a:r>
+              <a:t>100% Automated Testing: Comprehensive test suite validating data pipelines, connectors, econometric models, and web endpoints.</a:t>
             </a:r>
           </a:p>
         </p:txBody>

</xml_diff>